<commit_message>
Show original CSV sample rows in each weekly presentation
</commit_message>
<xml_diff>
--- a/assets/slides/week01.pptx
+++ b/assets/slides/week01.pptx
@@ -10,6 +10,7 @@
     <p:sldId id="258" r:id="rId10"/>
     <p:sldId id="259" r:id="rId11"/>
     <p:sldId id="260" r:id="rId12"/>
+    <p:sldId id="270" r:id="rId22"/>
     <p:sldId id="261" r:id="rId13"/>
     <p:sldId id="262" r:id="rId14"/>
     <p:sldId id="263" r:id="rId15"/>
@@ -1680,6 +1681,756 @@
           <a:p>
             <a:r>
               <a:t>完整教材與互動：https://knut921.github.io/datamining-course/week01.html</a:t>
+            </a:r>
+          </a:p>
+          <a:p>
+            <a:r>
+              <a:t>來源：中央研究院社會學研究所，2015 臺灣社會變遷基本調查。僅限學術用途，禁止商用。</a:t>
+            </a:r>
+          </a:p>
+        </p:txBody>
+      </p:sp>
+      <p:sp>
+        <p:nvSpPr>
+          <p:cNvPr id="4" name="Slide Number Placeholder 3"/>
+          <p:cNvSpPr>
+            <a:spLocks noGrp="1"/>
+          </p:cNvSpPr>
+          <p:nvPr>
+            <p:ph type="sldNum" idx="5" sz="quarter"/>
+          </p:nvPr>
+        </p:nvSpPr>
+        <p:spPr/>
+      </p:sp>
+    </p:spTree>
+  </p:cSld>
+  <p:clrMapOvr>
+    <a:masterClrMapping/>
+  </p:clrMapOvr>
+</p:notes>
+</file>
+
+<file path=ppt/notesSlides/notesSlide15.xml><?xml version="1.0" encoding="utf-8"?>
+<p:notes xmlns:a="http://schemas.openxmlformats.org/drawingml/2006/main" xmlns:p="http://schemas.openxmlformats.org/presentationml/2006/main" xmlns:r="http://schemas.openxmlformats.org/officeDocument/2006/relationships">
+  <p:cSld>
+    <p:spTree>
+      <p:nvGrpSpPr>
+        <p:cNvPr id="1" name=""/>
+        <p:cNvGrpSpPr/>
+        <p:nvPr/>
+      </p:nvGrpSpPr>
+      <p:grpSpPr>
+        <a:xfrm>
+          <a:off x="0" y="0"/>
+          <a:ext cx="0" cy="0"/>
+          <a:chOff x="0" y="0"/>
+          <a:chExt cx="0" cy="0"/>
+        </a:xfrm>
+      </p:grpSpPr>
+      <p:sp>
+        <p:nvSpPr>
+          <p:cNvPr id="2" name="Slide Image Placeholder 1"/>
+          <p:cNvSpPr>
+            <a:spLocks noGrp="1"/>
+          </p:cNvSpPr>
+          <p:nvPr>
+            <p:ph type="sldImg" idx="2"/>
+          </p:nvPr>
+        </p:nvSpPr>
+        <p:spPr/>
+      </p:sp>
+      <p:sp>
+        <p:nvSpPr>
+          <p:cNvPr id="3" name="Notes Placeholder 2"/>
+          <p:cNvSpPr>
+            <a:spLocks noGrp="1"/>
+          </p:cNvSpPr>
+          <p:nvPr>
+            <p:ph type="body" idx="3" sz="quarter"/>
+          </p:nvPr>
+        </p:nvSpPr>
+        <p:spPr/>
+        <p:txBody>
+          <a:bodyPr/>
+          <a:lstStyle/>
+          <a:p>
+            <a:r>
+              <a:t>完整教材與互動：https://knut921.github.io/datamining-course/week01.html</a:t>
+            </a:r>
+          </a:p>
+          <a:p>
+            <a:r>
+              <a:t>原始 CSV：https://knut921.github.io/datamining-course/data/臺灣青年資料健檢.csv</a:t>
+            </a:r>
+          </a:p>
+          <a:p>
+            <a:r>
+              <a:t>本頁只展示原檔前五筆，不代表整份資料的分布；未排序、未翻譯標籤、未四捨五入或改寫数值。</a:t>
+            </a:r>
+          </a:p>
+          <a:p>
+            <a:r>
+              <a:t>全部欄位及前五筆原始紀錄：</a:t>
+            </a:r>
+          </a:p>
+          <a:p>
+            <a:r>
+              <a:t>[</a:t>
+            </a:r>
+          </a:p>
+          <a:p>
+            <a:r>
+              <a:t>  {</a:t>
+            </a:r>
+          </a:p>
+          <a:p>
+            <a:r>
+              <a:t>    "樣本編號": "106117",</a:t>
+            </a:r>
+          </a:p>
+          <a:p>
+            <a:r>
+              <a:t>    "性別": "Female",</a:t>
+            </a:r>
+          </a:p>
+          <a:p>
+            <a:r>
+              <a:t>    "年齡": "23",</a:t>
+            </a:r>
+          </a:p>
+          <a:p>
+            <a:r>
+              <a:t>    "地區代碼": "1",</a:t>
+            </a:r>
+          </a:p>
+          <a:p>
+            <a:r>
+              <a:t>    "教育程度": "College (continue with 6a2)",</a:t>
+            </a:r>
+          </a:p>
+          <a:p>
+            <a:r>
+              <a:t>    "是否完成學業": "Yes, I graduated",</a:t>
+            </a:r>
+          </a:p>
+          <a:p>
+            <a:r>
+              <a:t>    "每日閱讀報紙分鐘": "30",</a:t>
+            </a:r>
+          </a:p>
+          <a:p>
+            <a:r>
+              <a:t>    "每日看電視分鐘": "60",</a:t>
+            </a:r>
+          </a:p>
+          <a:p>
+            <a:r>
+              <a:t>    "每日使用網路分鐘": "300",</a:t>
+            </a:r>
+          </a:p>
+          <a:p>
+            <a:r>
+              <a:t>    "每週閱讀雜誌分鐘": "0",</a:t>
+            </a:r>
+          </a:p>
+          <a:p>
+            <a:r>
+              <a:t>    "臺灣經濟滿意度": "Fairly dissatisfied",</a:t>
+            </a:r>
+          </a:p>
+          <a:p>
+            <a:r>
+              <a:t>    "政府施政滿意度": "Very dissatisfied",</a:t>
+            </a:r>
+          </a:p>
+          <a:p>
+            <a:r>
+              <a:t>    "民主運作滿意度": "Fairly satisfied",</a:t>
+            </a:r>
+          </a:p>
+          <a:p>
+            <a:r>
+              <a:t>    "收入足夠日常開支": "A little more than enough",</a:t>
+            </a:r>
+          </a:p>
+          <a:p>
+            <a:r>
+              <a:t>    "整體生活滿意度": "Fairly satisfied",</a:t>
+            </a:r>
+          </a:p>
+          <a:p>
+            <a:r>
+              <a:t>    "健康滿意度": "Fairly satisfied",</a:t>
+            </a:r>
+          </a:p>
+          <a:p>
+            <a:r>
+              <a:t>    "朋友關係滿意度": "Fairly satisfied",</a:t>
+            </a:r>
+          </a:p>
+          <a:p>
+            <a:r>
+              <a:t>    "工作滿意度": "Fairly satisfied",</a:t>
+            </a:r>
+          </a:p>
+          <a:p>
+            <a:r>
+              <a:t>    "近期快樂程度": "Fairly unhappy",</a:t>
+            </a:r>
+          </a:p>
+          <a:p>
+            <a:r>
+              <a:t>    "自評健康": "Fair",</a:t>
+            </a:r>
+          </a:p>
+          <a:p>
+            <a:r>
+              <a:t>    "覺得生活沒有希望": "A bit more than usual",</a:t>
+            </a:r>
+          </a:p>
+          <a:p>
+            <a:r>
+              <a:t>    "家庭月收入": "Don't know",</a:t>
+            </a:r>
+          </a:p>
+          <a:p>
+            <a:r>
+              <a:t>    "低生活滿意度": "0",</a:t>
+            </a:r>
+          </a:p>
+          <a:p>
+            <a:r>
+              <a:t>    "抽樣權數": "0.807775334231511"</a:t>
+            </a:r>
+          </a:p>
+          <a:p>
+            <a:r>
+              <a:t>  },</a:t>
+            </a:r>
+          </a:p>
+          <a:p>
+            <a:r>
+              <a:t>  {</a:t>
+            </a:r>
+          </a:p>
+          <a:p>
+            <a:r>
+              <a:t>    "樣本編號": "106208",</a:t>
+            </a:r>
+          </a:p>
+          <a:p>
+            <a:r>
+              <a:t>    "性別": "Female",</a:t>
+            </a:r>
+          </a:p>
+          <a:p>
+            <a:r>
+              <a:t>    "年齡": "21",</a:t>
+            </a:r>
+          </a:p>
+          <a:p>
+            <a:r>
+              <a:t>    "地區代碼": "1",</a:t>
+            </a:r>
+          </a:p>
+          <a:p>
+            <a:r>
+              <a:t>    "教育程度": "College (continue with 6a2)",</a:t>
+            </a:r>
+          </a:p>
+          <a:p>
+            <a:r>
+              <a:t>    "是否完成學業": "No, I didn't graduate",</a:t>
+            </a:r>
+          </a:p>
+          <a:p>
+            <a:r>
+              <a:t>    "每日閱讀報紙分鐘": "0",</a:t>
+            </a:r>
+          </a:p>
+          <a:p>
+            <a:r>
+              <a:t>    "每日看電視分鐘": "120",</a:t>
+            </a:r>
+          </a:p>
+          <a:p>
+            <a:r>
+              <a:t>    "每日使用網路分鐘": "180",</a:t>
+            </a:r>
+          </a:p>
+          <a:p>
+            <a:r>
+              <a:t>    "每週閱讀雜誌分鐘": "60",</a:t>
+            </a:r>
+          </a:p>
+          <a:p>
+            <a:r>
+              <a:t>    "臺灣經濟滿意度": "Not applicable",</a:t>
+            </a:r>
+          </a:p>
+          <a:p>
+            <a:r>
+              <a:t>    "政府施政滿意度": "Not applicable",</a:t>
+            </a:r>
+          </a:p>
+          <a:p>
+            <a:r>
+              <a:t>    "民主運作滿意度": "Not applicable",</a:t>
+            </a:r>
+          </a:p>
+          <a:p>
+            <a:r>
+              <a:t>    "收入足夠日常開支": "Much more than enough",</a:t>
+            </a:r>
+          </a:p>
+          <a:p>
+            <a:r>
+              <a:t>    "整體生活滿意度": "Pretty satisfied",</a:t>
+            </a:r>
+          </a:p>
+          <a:p>
+            <a:r>
+              <a:t>    "健康滿意度": "Fairly satisfied",</a:t>
+            </a:r>
+          </a:p>
+          <a:p>
+            <a:r>
+              <a:t>    "朋友關係滿意度": "Pretty satisfied",</a:t>
+            </a:r>
+          </a:p>
+          <a:p>
+            <a:r>
+              <a:t>    "工作滿意度": "I am currently unemployed",</a:t>
+            </a:r>
+          </a:p>
+          <a:p>
+            <a:r>
+              <a:t>    "近期快樂程度": "Pretty happy",</a:t>
+            </a:r>
+          </a:p>
+          <a:p>
+            <a:r>
+              <a:t>    "自評健康": "Very good",</a:t>
+            </a:r>
+          </a:p>
+          <a:p>
+            <a:r>
+              <a:t>    "覺得生活沒有希望": "Not at all",</a:t>
+            </a:r>
+          </a:p>
+          <a:p>
+            <a:r>
+              <a:t>    "家庭月收入": "NT$60,000 - NT$69,999",</a:t>
+            </a:r>
+          </a:p>
+          <a:p>
+            <a:r>
+              <a:t>    "低生活滿意度": "0",</a:t>
+            </a:r>
+          </a:p>
+          <a:p>
+            <a:r>
+              <a:t>    "抽樣權數": "0.807775334231511"</a:t>
+            </a:r>
+          </a:p>
+          <a:p>
+            <a:r>
+              <a:t>  },</a:t>
+            </a:r>
+          </a:p>
+          <a:p>
+            <a:r>
+              <a:t>  {</a:t>
+            </a:r>
+          </a:p>
+          <a:p>
+            <a:r>
+              <a:t>    "樣本編號": "110116",</a:t>
+            </a:r>
+          </a:p>
+          <a:p>
+            <a:r>
+              <a:t>    "性別": "Male",</a:t>
+            </a:r>
+          </a:p>
+          <a:p>
+            <a:r>
+              <a:t>    "年齡": "19",</a:t>
+            </a:r>
+          </a:p>
+          <a:p>
+            <a:r>
+              <a:t>    "地區代碼": "1",</a:t>
+            </a:r>
+          </a:p>
+          <a:p>
+            <a:r>
+              <a:t>    "教育程度": "College (continue with 6a2)",</a:t>
+            </a:r>
+          </a:p>
+          <a:p>
+            <a:r>
+              <a:t>    "是否完成學業": "Not applicable",</a:t>
+            </a:r>
+          </a:p>
+          <a:p>
+            <a:r>
+              <a:t>    "每日閱讀報紙分鐘": "0",</a:t>
+            </a:r>
+          </a:p>
+          <a:p>
+            <a:r>
+              <a:t>    "每日看電視分鐘": "120",</a:t>
+            </a:r>
+          </a:p>
+          <a:p>
+            <a:r>
+              <a:t>    "每日使用網路分鐘": "420",</a:t>
+            </a:r>
+          </a:p>
+          <a:p>
+            <a:r>
+              <a:t>    "每週閱讀雜誌分鐘": "0",</a:t>
+            </a:r>
+          </a:p>
+          <a:p>
+            <a:r>
+              <a:t>    "臺灣經濟滿意度": "Not applicable",</a:t>
+            </a:r>
+          </a:p>
+          <a:p>
+            <a:r>
+              <a:t>    "政府施政滿意度": "Not applicable",</a:t>
+            </a:r>
+          </a:p>
+          <a:p>
+            <a:r>
+              <a:t>    "民主運作滿意度": "Not applicable",</a:t>
+            </a:r>
+          </a:p>
+          <a:p>
+            <a:r>
+              <a:t>    "收入足夠日常開支": "A little more than enough",</a:t>
+            </a:r>
+          </a:p>
+          <a:p>
+            <a:r>
+              <a:t>    "整體生活滿意度": "Fairly satisfied",</a:t>
+            </a:r>
+          </a:p>
+          <a:p>
+            <a:r>
+              <a:t>    "健康滿意度": "Fairly dissatisfied",</a:t>
+            </a:r>
+          </a:p>
+          <a:p>
+            <a:r>
+              <a:t>    "朋友關係滿意度": "Fairly satisfied",</a:t>
+            </a:r>
+          </a:p>
+          <a:p>
+            <a:r>
+              <a:t>    "工作滿意度": "I am currently unemployed",</a:t>
+            </a:r>
+          </a:p>
+          <a:p>
+            <a:r>
+              <a:t>    "近期快樂程度": "Fairly happy",</a:t>
+            </a:r>
+          </a:p>
+          <a:p>
+            <a:r>
+              <a:t>    "自評健康": "Poor",</a:t>
+            </a:r>
+          </a:p>
+          <a:p>
+            <a:r>
+              <a:t>    "覺得生活沒有希望": "Same as usual",</a:t>
+            </a:r>
+          </a:p>
+          <a:p>
+            <a:r>
+              <a:t>    "家庭月收入": "Don't know",</a:t>
+            </a:r>
+          </a:p>
+          <a:p>
+            <a:r>
+              <a:t>    "低生活滿意度": "0",</a:t>
+            </a:r>
+          </a:p>
+          <a:p>
+            <a:r>
+              <a:t>    "抽樣權數": "0.807775334231511"</a:t>
+            </a:r>
+          </a:p>
+          <a:p>
+            <a:r>
+              <a:t>  },</a:t>
+            </a:r>
+          </a:p>
+          <a:p>
+            <a:r>
+              <a:t>  {</a:t>
+            </a:r>
+          </a:p>
+          <a:p>
+            <a:r>
+              <a:t>    "樣本編號": "110119",</a:t>
+            </a:r>
+          </a:p>
+          <a:p>
+            <a:r>
+              <a:t>    "性別": "Male",</a:t>
+            </a:r>
+          </a:p>
+          <a:p>
+            <a:r>
+              <a:t>    "年齡": "24",</a:t>
+            </a:r>
+          </a:p>
+          <a:p>
+            <a:r>
+              <a:t>    "地區代碼": "1",</a:t>
+            </a:r>
+          </a:p>
+          <a:p>
+            <a:r>
+              <a:t>    "教育程度": "College (continue with 6a2)",</a:t>
+            </a:r>
+          </a:p>
+          <a:p>
+            <a:r>
+              <a:t>    "是否完成學業": "Yes, I graduated",</a:t>
+            </a:r>
+          </a:p>
+          <a:p>
+            <a:r>
+              <a:t>    "每日閱讀報紙分鐘": "3",</a:t>
+            </a:r>
+          </a:p>
+          <a:p>
+            <a:r>
+              <a:t>    "每日看電視分鐘": "60",</a:t>
+            </a:r>
+          </a:p>
+          <a:p>
+            <a:r>
+              <a:t>    "每日使用網路分鐘": "240",</a:t>
+            </a:r>
+          </a:p>
+          <a:p>
+            <a:r>
+              <a:t>    "每週閱讀雜誌分鐘": "120",</a:t>
+            </a:r>
+          </a:p>
+          <a:p>
+            <a:r>
+              <a:t>    "臺灣經濟滿意度": "Fairly satisfied",</a:t>
+            </a:r>
+          </a:p>
+          <a:p>
+            <a:r>
+              <a:t>    "政府施政滿意度": "Fairly satisfied",</a:t>
+            </a:r>
+          </a:p>
+          <a:p>
+            <a:r>
+              <a:t>    "民主運作滿意度": "Fairly dissatisfied",</a:t>
+            </a:r>
+          </a:p>
+          <a:p>
+            <a:r>
+              <a:t>    "收入足夠日常開支": "A little more than enough",</a:t>
+            </a:r>
+          </a:p>
+          <a:p>
+            <a:r>
+              <a:t>    "整體生活滿意度": "Fairly satisfied",</a:t>
+            </a:r>
+          </a:p>
+          <a:p>
+            <a:r>
+              <a:t>    "健康滿意度": "Fairly satisfied",</a:t>
+            </a:r>
+          </a:p>
+          <a:p>
+            <a:r>
+              <a:t>    "朋友關係滿意度": "Fairly satisfied",</a:t>
+            </a:r>
+          </a:p>
+          <a:p>
+            <a:r>
+              <a:t>    "工作滿意度": "I am currently unemployed",</a:t>
+            </a:r>
+          </a:p>
+          <a:p>
+            <a:r>
+              <a:t>    "近期快樂程度": "Fairly happy",</a:t>
+            </a:r>
+          </a:p>
+          <a:p>
+            <a:r>
+              <a:t>    "自評健康": "Fair",</a:t>
+            </a:r>
+          </a:p>
+          <a:p>
+            <a:r>
+              <a:t>    "覺得生活沒有希望": "Same as usual",</a:t>
+            </a:r>
+          </a:p>
+          <a:p>
+            <a:r>
+              <a:t>    "家庭月收入": "NT$300,000 - NT$399,999",</a:t>
+            </a:r>
+          </a:p>
+          <a:p>
+            <a:r>
+              <a:t>    "低生活滿意度": "0",</a:t>
+            </a:r>
+          </a:p>
+          <a:p>
+            <a:r>
+              <a:t>    "抽樣權數": "0.807775334231511"</a:t>
+            </a:r>
+          </a:p>
+          <a:p>
+            <a:r>
+              <a:t>  },</a:t>
+            </a:r>
+          </a:p>
+          <a:p>
+            <a:r>
+              <a:t>  {</a:t>
+            </a:r>
+          </a:p>
+          <a:p>
+            <a:r>
+              <a:t>    "樣本編號": "110219",</a:t>
+            </a:r>
+          </a:p>
+          <a:p>
+            <a:r>
+              <a:t>    "性別": "Male",</a:t>
+            </a:r>
+          </a:p>
+          <a:p>
+            <a:r>
+              <a:t>    "年齡": "19",</a:t>
+            </a:r>
+          </a:p>
+          <a:p>
+            <a:r>
+              <a:t>    "地區代碼": "1",</a:t>
+            </a:r>
+          </a:p>
+          <a:p>
+            <a:r>
+              <a:t>    "教育程度": "College (continue with 6a2)",</a:t>
+            </a:r>
+          </a:p>
+          <a:p>
+            <a:r>
+              <a:t>    "是否完成學業": "No, I am still a student",</a:t>
+            </a:r>
+          </a:p>
+          <a:p>
+            <a:r>
+              <a:t>    "每日閱讀報紙分鐘": "0",</a:t>
+            </a:r>
+          </a:p>
+          <a:p>
+            <a:r>
+              <a:t>    "每日看電視分鐘": "120",</a:t>
+            </a:r>
+          </a:p>
+          <a:p>
+            <a:r>
+              <a:t>    "每日使用網路分鐘": "480",</a:t>
+            </a:r>
+          </a:p>
+          <a:p>
+            <a:r>
+              <a:t>    "每週閱讀雜誌分鐘": "0",</a:t>
+            </a:r>
+          </a:p>
+          <a:p>
+            <a:r>
+              <a:t>    "臺灣經濟滿意度": "Fairly dissatisfied",</a:t>
+            </a:r>
+          </a:p>
+          <a:p>
+            <a:r>
+              <a:t>    "政府施政滿意度": "Fairly dissatisfied",</a:t>
+            </a:r>
+          </a:p>
+          <a:p>
+            <a:r>
+              <a:t>    "民主運作滿意度": "Very satisfied",</a:t>
+            </a:r>
+          </a:p>
+          <a:p>
+            <a:r>
+              <a:t>    "收入足夠日常開支": "A little more than enough",</a:t>
+            </a:r>
+          </a:p>
+          <a:p>
+            <a:r>
+              <a:t>    "整體生活滿意度": "Fairly satisfied",</a:t>
+            </a:r>
+          </a:p>
+          <a:p>
+            <a:r>
+              <a:t>    "健康滿意度": "Fairly dissatisfied",</a:t>
+            </a:r>
+          </a:p>
+          <a:p>
+            <a:r>
+              <a:t>    "朋友關係滿意度": "Fairly satisfied",</a:t>
+            </a:r>
+          </a:p>
+          <a:p>
+            <a:r>
+              <a:t>    "工作滿意度": "I am currently unemployed",</a:t>
+            </a:r>
+          </a:p>
+          <a:p>
+            <a:r>
+              <a:t>    "近期快樂程度": "Fairly happy",</a:t>
+            </a:r>
+          </a:p>
+          <a:p>
+            <a:r>
+              <a:t>    "自評健康": "Good",</a:t>
+            </a:r>
+          </a:p>
+          <a:p>
+            <a:r>
+              <a:t>    "覺得生活沒有希望": "Not at all",</a:t>
+            </a:r>
+          </a:p>
+          <a:p>
+            <a:r>
+              <a:t>    "家庭月收入": "Don't know",</a:t>
+            </a:r>
+          </a:p>
+          <a:p>
+            <a:r>
+              <a:t>    "低生活滿意度": "0",</a:t>
+            </a:r>
+          </a:p>
+          <a:p>
+            <a:r>
+              <a:t>    "抽樣權數": "0.807775334231511"</a:t>
+            </a:r>
+          </a:p>
+          <a:p>
+            <a:r>
+              <a:t>  }</a:t>
+            </a:r>
+          </a:p>
+          <a:p>
+            <a:r>
+              <a:t>]</a:t>
             </a:r>
           </a:p>
           <a:p>
@@ -5884,7 +6635,7 @@
               <a:rPr>
                 <a:ea typeface="PingFang TC"/>
               </a:rPr>
-              <a:t>10</a:t>
+              <a:t>11</a:t>
             </a:r>
           </a:p>
         </p:txBody>
@@ -6629,7 +7380,7 @@
               <a:rPr>
                 <a:ea typeface="PingFang TC"/>
               </a:rPr>
-              <a:t>11</a:t>
+              <a:t>12</a:t>
             </a:r>
           </a:p>
         </p:txBody>
@@ -7374,7 +8125,7 @@
               <a:rPr>
                 <a:ea typeface="PingFang TC"/>
               </a:rPr>
-              <a:t>12</a:t>
+              <a:t>13</a:t>
             </a:r>
           </a:p>
         </p:txBody>
@@ -7780,7 +8531,7 @@
               <a:rPr>
                 <a:ea typeface="PingFang TC"/>
               </a:rPr>
-              <a:t>13</a:t>
+              <a:t>14</a:t>
             </a:r>
           </a:p>
         </p:txBody>
@@ -8525,7 +9276,7 @@
               <a:rPr>
                 <a:ea typeface="PingFang TC"/>
               </a:rPr>
-              <a:t>14</a:t>
+              <a:t>15</a:t>
             </a:r>
           </a:p>
         </p:txBody>
@@ -8695,6 +9446,1271 @@
                 <a:ea typeface="PingFang TC"/>
               </a:rPr>
               <a:t>開啟完整教材、下載 CSV 與操作互動實驗 →</a:t>
+            </a:r>
+          </a:p>
+        </p:txBody>
+      </p:sp>
+    </p:spTree>
+  </p:cSld>
+  <p:clrMapOvr>
+    <a:masterClrMapping/>
+  </p:clrMapOvr>
+</p:sld>
+</file>
+
+<file path=ppt/slides/slide15.xml><?xml version="1.0" encoding="utf-8"?>
+<p:sld xmlns:a="http://schemas.openxmlformats.org/drawingml/2006/main" xmlns:p="http://schemas.openxmlformats.org/presentationml/2006/main" xmlns:r="http://schemas.openxmlformats.org/officeDocument/2006/relationships">
+  <p:cSld>
+    <p:bg>
+      <p:bgPr>
+        <a:solidFill>
+          <a:srgbClr val="F5F3EF"/>
+        </a:solidFill>
+        <a:effectLst/>
+      </p:bgPr>
+    </p:bg>
+    <p:spTree>
+      <p:nvGrpSpPr>
+        <p:cNvPr id="1" name=""/>
+        <p:cNvGrpSpPr/>
+        <p:nvPr/>
+      </p:nvGrpSpPr>
+      <p:grpSpPr/>
+      <p:sp>
+        <p:nvSpPr>
+          <p:cNvPr id="2" name="Rectangle 1"/>
+          <p:cNvSpPr/>
+          <p:nvPr/>
+        </p:nvSpPr>
+        <p:spPr>
+          <a:xfrm>
+            <a:off x="0" y="0"/>
+            <a:ext cx="146304" cy="6858000"/>
+          </a:xfrm>
+          <a:prstGeom prst="rect">
+            <a:avLst/>
+          </a:prstGeom>
+          <a:solidFill>
+            <a:srgbClr val="B5622A"/>
+          </a:solidFill>
+          <a:ln>
+            <a:noFill/>
+          </a:ln>
+        </p:spPr>
+        <p:style>
+          <a:lnRef idx="1">
+            <a:schemeClr val="accent1"/>
+          </a:lnRef>
+          <a:fillRef idx="3">
+            <a:schemeClr val="accent1"/>
+          </a:fillRef>
+          <a:effectRef idx="2">
+            <a:schemeClr val="accent1"/>
+          </a:effectRef>
+          <a:fontRef idx="minor">
+            <a:schemeClr val="lt1"/>
+          </a:fontRef>
+        </p:style>
+        <p:txBody>
+          <a:bodyPr rtlCol="0" anchor="ctr"/>
+          <a:lstStyle/>
+          <a:p>
+            <a:pPr algn="ctr"/>
+          </a:p>
+        </p:txBody>
+      </p:sp>
+      <p:sp>
+        <p:nvSpPr>
+          <p:cNvPr id="3" name="TextBox 2"/>
+          <p:cNvSpPr txBox="1"/>
+          <p:nvPr/>
+        </p:nvSpPr>
+        <p:spPr>
+          <a:xfrm>
+            <a:off x="548640" y="274320"/>
+            <a:ext cx="10058400" cy="365760"/>
+          </a:xfrm>
+          <a:prstGeom prst="rect">
+            <a:avLst/>
+          </a:prstGeom>
+          <a:noFill/>
+        </p:spPr>
+        <p:txBody>
+          <a:bodyPr wrap="square" lIns="0" rIns="0" tIns="0" bIns="0">
+            <a:spAutoFit/>
+          </a:bodyPr>
+          <a:lstStyle/>
+          <a:p>
+            <a:pPr>
+              <a:defRPr sz="1300" b="1">
+                <a:solidFill>
+                  <a:srgbClr val="3B4A8C"/>
+                </a:solidFill>
+                <a:latin typeface="PingFang TC"/>
+              </a:defRPr>
+            </a:pPr>
+            <a:r>
+              <a:t>DATA MINING  /  WEEK 01</a:t>
+            </a:r>
+          </a:p>
+        </p:txBody>
+      </p:sp>
+      <p:sp>
+        <p:nvSpPr>
+          <p:cNvPr id="4" name="TextBox 3"/>
+          <p:cNvSpPr txBox="1"/>
+          <p:nvPr/>
+        </p:nvSpPr>
+        <p:spPr>
+          <a:xfrm>
+            <a:off x="548640" y="841248"/>
+            <a:ext cx="11064240" cy="1078992"/>
+          </a:xfrm>
+          <a:prstGeom prst="rect">
+            <a:avLst/>
+          </a:prstGeom>
+          <a:noFill/>
+        </p:spPr>
+        <p:txBody>
+          <a:bodyPr wrap="square" lIns="0" rIns="0" tIns="0" bIns="0">
+            <a:spAutoFit/>
+          </a:bodyPr>
+          <a:lstStyle/>
+          <a:p>
+            <a:pPr>
+              <a:defRPr sz="3000" b="1">
+                <a:solidFill>
+                  <a:srgbClr val="20283F"/>
+                </a:solidFill>
+                <a:latin typeface="PingFang TC"/>
+              </a:defRPr>
+            </a:pPr>
+            <a:r>
+              <a:t>範例檔原始資料｜先看資料長什麼樣子</a:t>
+            </a:r>
+          </a:p>
+        </p:txBody>
+      </p:sp>
+      <p:sp>
+        <p:nvSpPr>
+          <p:cNvPr id="5" name="TextBox 4"/>
+          <p:cNvSpPr txBox="1"/>
+          <p:nvPr/>
+        </p:nvSpPr>
+        <p:spPr>
+          <a:xfrm>
+            <a:off x="594360" y="1673352"/>
+            <a:ext cx="10881360" cy="365760"/>
+          </a:xfrm>
+          <a:prstGeom prst="rect">
+            <a:avLst/>
+          </a:prstGeom>
+          <a:noFill/>
+        </p:spPr>
+        <p:txBody>
+          <a:bodyPr wrap="square" lIns="0" rIns="0" tIns="0" bIns="0">
+            <a:spAutoFit/>
+          </a:bodyPr>
+          <a:lstStyle/>
+          <a:p>
+            <a:pPr>
+              <a:defRPr sz="1800" b="1">
+                <a:solidFill>
+                  <a:srgbClr val="3B4A8C"/>
+                </a:solidFill>
+                <a:latin typeface="PingFang TC"/>
+              </a:defRPr>
+            </a:pPr>
+            <a:r>
+              <a:t>臺灣青年資料健檢.csv</a:t>
+            </a:r>
+          </a:p>
+        </p:txBody>
+      </p:sp>
+      <p:sp>
+        <p:nvSpPr>
+          <p:cNvPr id="6" name="TextBox 5"/>
+          <p:cNvSpPr txBox="1"/>
+          <p:nvPr/>
+        </p:nvSpPr>
+        <p:spPr>
+          <a:xfrm>
+            <a:off x="594360" y="2075688"/>
+            <a:ext cx="10972800" cy="365760"/>
+          </a:xfrm>
+          <a:prstGeom prst="rect">
+            <a:avLst/>
+          </a:prstGeom>
+          <a:noFill/>
+        </p:spPr>
+        <p:txBody>
+          <a:bodyPr wrap="square" lIns="0" rIns="0" tIns="0" bIns="0">
+            <a:spAutoFit/>
+          </a:bodyPr>
+          <a:lstStyle/>
+          <a:p>
+            <a:pPr>
+              <a:defRPr sz="1300" b="0">
+                <a:solidFill>
+                  <a:srgbClr val="596078"/>
+                </a:solidFill>
+                <a:latin typeface="PingFang TC"/>
+              </a:defRPr>
+            </a:pPr>
+            <a:r>
+              <a:t>原檔 212 筆、24 欄｜下表依原順序顯示前 5 筆、選列 6 欄；欄名與儲存格保留原值。</a:t>
+            </a:r>
+          </a:p>
+        </p:txBody>
+      </p:sp>
+      <p:graphicFrame>
+        <p:nvGraphicFramePr>
+          <p:cNvPr id="7" name="Table 6"/>
+          <p:cNvGraphicFramePr>
+            <a:graphicFrameLocks noGrp="1"/>
+          </p:cNvGraphicFramePr>
+          <p:nvPr/>
+        </p:nvGraphicFramePr>
+        <p:xfrm>
+          <a:off x="594360" y="2587752"/>
+          <a:ext cx="10972800" cy="2788920"/>
+        </p:xfrm>
+        <a:graphic>
+          <a:graphicData uri="http://schemas.openxmlformats.org/drawingml/2006/table">
+            <a:tbl>
+              <a:tblPr firstRow="1" bandRow="1">
+                <a:tableStyleId>{5C22544A-7EE6-4342-B048-85BDC9FD1C3A}</a:tableStyleId>
+              </a:tblPr>
+              <a:tblGrid>
+                <a:gridCol w="1188720"/>
+                <a:gridCol w="1005840"/>
+                <a:gridCol w="731520"/>
+                <a:gridCol w="1188720"/>
+                <a:gridCol w="2286000"/>
+                <a:gridCol w="4572000"/>
+              </a:tblGrid>
+              <a:tr h="548640">
+                <a:tc>
+                  <a:txBody>
+                    <a:bodyPr/>
+                    <a:lstStyle/>
+                    <a:p>
+                      <a:pPr>
+                        <a:defRPr sz="1400" b="1">
+                          <a:solidFill>
+                            <a:srgbClr val="FFFFFF"/>
+                          </a:solidFill>
+                          <a:latin typeface="PingFang TC"/>
+                        </a:defRPr>
+                      </a:pPr>
+                      <a:r>
+                        <a:t>樣本編號</a:t>
+                      </a:r>
+                    </a:p>
+                  </a:txBody>
+                  <a:tcPr marL="64008" marR="64008" marT="45720" marB="45720">
+                    <a:solidFill>
+                      <a:srgbClr val="3B4A8C"/>
+                    </a:solidFill>
+                  </a:tcPr>
+                </a:tc>
+                <a:tc>
+                  <a:txBody>
+                    <a:bodyPr/>
+                    <a:lstStyle/>
+                    <a:p>
+                      <a:pPr>
+                        <a:defRPr sz="1400" b="1">
+                          <a:solidFill>
+                            <a:srgbClr val="FFFFFF"/>
+                          </a:solidFill>
+                          <a:latin typeface="PingFang TC"/>
+                        </a:defRPr>
+                      </a:pPr>
+                      <a:r>
+                        <a:t>性別</a:t>
+                      </a:r>
+                    </a:p>
+                  </a:txBody>
+                  <a:tcPr marL="64008" marR="64008" marT="45720" marB="45720">
+                    <a:solidFill>
+                      <a:srgbClr val="3B4A8C"/>
+                    </a:solidFill>
+                  </a:tcPr>
+                </a:tc>
+                <a:tc>
+                  <a:txBody>
+                    <a:bodyPr/>
+                    <a:lstStyle/>
+                    <a:p>
+                      <a:pPr>
+                        <a:defRPr sz="1400" b="1">
+                          <a:solidFill>
+                            <a:srgbClr val="FFFFFF"/>
+                          </a:solidFill>
+                          <a:latin typeface="PingFang TC"/>
+                        </a:defRPr>
+                      </a:pPr>
+                      <a:r>
+                        <a:t>年齡</a:t>
+                      </a:r>
+                    </a:p>
+                  </a:txBody>
+                  <a:tcPr marL="64008" marR="64008" marT="45720" marB="45720">
+                    <a:solidFill>
+                      <a:srgbClr val="3B4A8C"/>
+                    </a:solidFill>
+                  </a:tcPr>
+                </a:tc>
+                <a:tc>
+                  <a:txBody>
+                    <a:bodyPr/>
+                    <a:lstStyle/>
+                    <a:p>
+                      <a:pPr>
+                        <a:defRPr sz="1400" b="1">
+                          <a:solidFill>
+                            <a:srgbClr val="FFFFFF"/>
+                          </a:solidFill>
+                          <a:latin typeface="PingFang TC"/>
+                        </a:defRPr>
+                      </a:pPr>
+                      <a:r>
+                        <a:t>地區代碼</a:t>
+                      </a:r>
+                    </a:p>
+                  </a:txBody>
+                  <a:tcPr marL="64008" marR="64008" marT="45720" marB="45720">
+                    <a:solidFill>
+                      <a:srgbClr val="3B4A8C"/>
+                    </a:solidFill>
+                  </a:tcPr>
+                </a:tc>
+                <a:tc>
+                  <a:txBody>
+                    <a:bodyPr/>
+                    <a:lstStyle/>
+                    <a:p>
+                      <a:pPr>
+                        <a:defRPr sz="1400" b="1">
+                          <a:solidFill>
+                            <a:srgbClr val="FFFFFF"/>
+                          </a:solidFill>
+                          <a:latin typeface="PingFang TC"/>
+                        </a:defRPr>
+                      </a:pPr>
+                      <a:r>
+                        <a:t>每日使用網路分鐘</a:t>
+                      </a:r>
+                    </a:p>
+                  </a:txBody>
+                  <a:tcPr marL="64008" marR="64008" marT="45720" marB="45720">
+                    <a:solidFill>
+                      <a:srgbClr val="3B4A8C"/>
+                    </a:solidFill>
+                  </a:tcPr>
+                </a:tc>
+                <a:tc>
+                  <a:txBody>
+                    <a:bodyPr/>
+                    <a:lstStyle/>
+                    <a:p>
+                      <a:pPr>
+                        <a:defRPr sz="1400" b="1">
+                          <a:solidFill>
+                            <a:srgbClr val="FFFFFF"/>
+                          </a:solidFill>
+                          <a:latin typeface="PingFang TC"/>
+                        </a:defRPr>
+                      </a:pPr>
+                      <a:r>
+                        <a:t>家庭月收入</a:t>
+                      </a:r>
+                    </a:p>
+                  </a:txBody>
+                  <a:tcPr marL="64008" marR="64008" marT="45720" marB="45720">
+                    <a:solidFill>
+                      <a:srgbClr val="3B4A8C"/>
+                    </a:solidFill>
+                  </a:tcPr>
+                </a:tc>
+              </a:tr>
+              <a:tr h="448056">
+                <a:tc>
+                  <a:txBody>
+                    <a:bodyPr/>
+                    <a:lstStyle/>
+                    <a:p>
+                      <a:pPr>
+                        <a:defRPr sz="1400" b="0">
+                          <a:solidFill>
+                            <a:srgbClr val="20283F"/>
+                          </a:solidFill>
+                          <a:latin typeface="PingFang TC"/>
+                        </a:defRPr>
+                      </a:pPr>
+                      <a:r>
+                        <a:t>106117</a:t>
+                      </a:r>
+                    </a:p>
+                  </a:txBody>
+                  <a:tcPr marL="64008" marR="64008" marT="45720" marB="45720">
+                    <a:solidFill>
+                      <a:srgbClr val="FFFFFF"/>
+                    </a:solidFill>
+                  </a:tcPr>
+                </a:tc>
+                <a:tc>
+                  <a:txBody>
+                    <a:bodyPr/>
+                    <a:lstStyle/>
+                    <a:p>
+                      <a:pPr>
+                        <a:defRPr sz="1400" b="0">
+                          <a:solidFill>
+                            <a:srgbClr val="20283F"/>
+                          </a:solidFill>
+                          <a:latin typeface="PingFang TC"/>
+                        </a:defRPr>
+                      </a:pPr>
+                      <a:r>
+                        <a:t>Female</a:t>
+                      </a:r>
+                    </a:p>
+                  </a:txBody>
+                  <a:tcPr marL="64008" marR="64008" marT="45720" marB="45720">
+                    <a:solidFill>
+                      <a:srgbClr val="FFFFFF"/>
+                    </a:solidFill>
+                  </a:tcPr>
+                </a:tc>
+                <a:tc>
+                  <a:txBody>
+                    <a:bodyPr/>
+                    <a:lstStyle/>
+                    <a:p>
+                      <a:pPr>
+                        <a:defRPr sz="1400" b="0">
+                          <a:solidFill>
+                            <a:srgbClr val="20283F"/>
+                          </a:solidFill>
+                          <a:latin typeface="PingFang TC"/>
+                        </a:defRPr>
+                      </a:pPr>
+                      <a:r>
+                        <a:t>23</a:t>
+                      </a:r>
+                    </a:p>
+                  </a:txBody>
+                  <a:tcPr marL="64008" marR="64008" marT="45720" marB="45720">
+                    <a:solidFill>
+                      <a:srgbClr val="FFFFFF"/>
+                    </a:solidFill>
+                  </a:tcPr>
+                </a:tc>
+                <a:tc>
+                  <a:txBody>
+                    <a:bodyPr/>
+                    <a:lstStyle/>
+                    <a:p>
+                      <a:pPr>
+                        <a:defRPr sz="1400" b="0">
+                          <a:solidFill>
+                            <a:srgbClr val="20283F"/>
+                          </a:solidFill>
+                          <a:latin typeface="PingFang TC"/>
+                        </a:defRPr>
+                      </a:pPr>
+                      <a:r>
+                        <a:t>1</a:t>
+                      </a:r>
+                    </a:p>
+                  </a:txBody>
+                  <a:tcPr marL="64008" marR="64008" marT="45720" marB="45720">
+                    <a:solidFill>
+                      <a:srgbClr val="FFFFFF"/>
+                    </a:solidFill>
+                  </a:tcPr>
+                </a:tc>
+                <a:tc>
+                  <a:txBody>
+                    <a:bodyPr/>
+                    <a:lstStyle/>
+                    <a:p>
+                      <a:pPr>
+                        <a:defRPr sz="1400" b="0">
+                          <a:solidFill>
+                            <a:srgbClr val="20283F"/>
+                          </a:solidFill>
+                          <a:latin typeface="PingFang TC"/>
+                        </a:defRPr>
+                      </a:pPr>
+                      <a:r>
+                        <a:t>300</a:t>
+                      </a:r>
+                    </a:p>
+                  </a:txBody>
+                  <a:tcPr marL="64008" marR="64008" marT="45720" marB="45720">
+                    <a:solidFill>
+                      <a:srgbClr val="FFFFFF"/>
+                    </a:solidFill>
+                  </a:tcPr>
+                </a:tc>
+                <a:tc>
+                  <a:txBody>
+                    <a:bodyPr/>
+                    <a:lstStyle/>
+                    <a:p>
+                      <a:pPr>
+                        <a:defRPr sz="1400" b="0">
+                          <a:solidFill>
+                            <a:srgbClr val="20283F"/>
+                          </a:solidFill>
+                          <a:latin typeface="PingFang TC"/>
+                        </a:defRPr>
+                      </a:pPr>
+                      <a:r>
+                        <a:t>Don't know</a:t>
+                      </a:r>
+                    </a:p>
+                  </a:txBody>
+                  <a:tcPr marL="64008" marR="64008" marT="45720" marB="45720">
+                    <a:solidFill>
+                      <a:srgbClr val="FFFFFF"/>
+                    </a:solidFill>
+                  </a:tcPr>
+                </a:tc>
+              </a:tr>
+              <a:tr h="448056">
+                <a:tc>
+                  <a:txBody>
+                    <a:bodyPr/>
+                    <a:lstStyle/>
+                    <a:p>
+                      <a:pPr>
+                        <a:defRPr sz="1400" b="0">
+                          <a:solidFill>
+                            <a:srgbClr val="20283F"/>
+                          </a:solidFill>
+                          <a:latin typeface="PingFang TC"/>
+                        </a:defRPr>
+                      </a:pPr>
+                      <a:r>
+                        <a:t>106208</a:t>
+                      </a:r>
+                    </a:p>
+                  </a:txBody>
+                  <a:tcPr marL="64008" marR="64008" marT="45720" marB="45720">
+                    <a:solidFill>
+                      <a:srgbClr val="E9ECF7"/>
+                    </a:solidFill>
+                  </a:tcPr>
+                </a:tc>
+                <a:tc>
+                  <a:txBody>
+                    <a:bodyPr/>
+                    <a:lstStyle/>
+                    <a:p>
+                      <a:pPr>
+                        <a:defRPr sz="1400" b="0">
+                          <a:solidFill>
+                            <a:srgbClr val="20283F"/>
+                          </a:solidFill>
+                          <a:latin typeface="PingFang TC"/>
+                        </a:defRPr>
+                      </a:pPr>
+                      <a:r>
+                        <a:t>Female</a:t>
+                      </a:r>
+                    </a:p>
+                  </a:txBody>
+                  <a:tcPr marL="64008" marR="64008" marT="45720" marB="45720">
+                    <a:solidFill>
+                      <a:srgbClr val="E9ECF7"/>
+                    </a:solidFill>
+                  </a:tcPr>
+                </a:tc>
+                <a:tc>
+                  <a:txBody>
+                    <a:bodyPr/>
+                    <a:lstStyle/>
+                    <a:p>
+                      <a:pPr>
+                        <a:defRPr sz="1400" b="0">
+                          <a:solidFill>
+                            <a:srgbClr val="20283F"/>
+                          </a:solidFill>
+                          <a:latin typeface="PingFang TC"/>
+                        </a:defRPr>
+                      </a:pPr>
+                      <a:r>
+                        <a:t>21</a:t>
+                      </a:r>
+                    </a:p>
+                  </a:txBody>
+                  <a:tcPr marL="64008" marR="64008" marT="45720" marB="45720">
+                    <a:solidFill>
+                      <a:srgbClr val="E9ECF7"/>
+                    </a:solidFill>
+                  </a:tcPr>
+                </a:tc>
+                <a:tc>
+                  <a:txBody>
+                    <a:bodyPr/>
+                    <a:lstStyle/>
+                    <a:p>
+                      <a:pPr>
+                        <a:defRPr sz="1400" b="0">
+                          <a:solidFill>
+                            <a:srgbClr val="20283F"/>
+                          </a:solidFill>
+                          <a:latin typeface="PingFang TC"/>
+                        </a:defRPr>
+                      </a:pPr>
+                      <a:r>
+                        <a:t>1</a:t>
+                      </a:r>
+                    </a:p>
+                  </a:txBody>
+                  <a:tcPr marL="64008" marR="64008" marT="45720" marB="45720">
+                    <a:solidFill>
+                      <a:srgbClr val="E9ECF7"/>
+                    </a:solidFill>
+                  </a:tcPr>
+                </a:tc>
+                <a:tc>
+                  <a:txBody>
+                    <a:bodyPr/>
+                    <a:lstStyle/>
+                    <a:p>
+                      <a:pPr>
+                        <a:defRPr sz="1400" b="0">
+                          <a:solidFill>
+                            <a:srgbClr val="20283F"/>
+                          </a:solidFill>
+                          <a:latin typeface="PingFang TC"/>
+                        </a:defRPr>
+                      </a:pPr>
+                      <a:r>
+                        <a:t>180</a:t>
+                      </a:r>
+                    </a:p>
+                  </a:txBody>
+                  <a:tcPr marL="64008" marR="64008" marT="45720" marB="45720">
+                    <a:solidFill>
+                      <a:srgbClr val="E9ECF7"/>
+                    </a:solidFill>
+                  </a:tcPr>
+                </a:tc>
+                <a:tc>
+                  <a:txBody>
+                    <a:bodyPr/>
+                    <a:lstStyle/>
+                    <a:p>
+                      <a:pPr>
+                        <a:defRPr sz="1400" b="0">
+                          <a:solidFill>
+                            <a:srgbClr val="20283F"/>
+                          </a:solidFill>
+                          <a:latin typeface="PingFang TC"/>
+                        </a:defRPr>
+                      </a:pPr>
+                      <a:r>
+                        <a:t>NT$60,000 - NT$69,999</a:t>
+                      </a:r>
+                    </a:p>
+                  </a:txBody>
+                  <a:tcPr marL="64008" marR="64008" marT="45720" marB="45720">
+                    <a:solidFill>
+                      <a:srgbClr val="E9ECF7"/>
+                    </a:solidFill>
+                  </a:tcPr>
+                </a:tc>
+              </a:tr>
+              <a:tr h="448056">
+                <a:tc>
+                  <a:txBody>
+                    <a:bodyPr/>
+                    <a:lstStyle/>
+                    <a:p>
+                      <a:pPr>
+                        <a:defRPr sz="1400" b="0">
+                          <a:solidFill>
+                            <a:srgbClr val="20283F"/>
+                          </a:solidFill>
+                          <a:latin typeface="PingFang TC"/>
+                        </a:defRPr>
+                      </a:pPr>
+                      <a:r>
+                        <a:t>110116</a:t>
+                      </a:r>
+                    </a:p>
+                  </a:txBody>
+                  <a:tcPr marL="64008" marR="64008" marT="45720" marB="45720">
+                    <a:solidFill>
+                      <a:srgbClr val="FFFFFF"/>
+                    </a:solidFill>
+                  </a:tcPr>
+                </a:tc>
+                <a:tc>
+                  <a:txBody>
+                    <a:bodyPr/>
+                    <a:lstStyle/>
+                    <a:p>
+                      <a:pPr>
+                        <a:defRPr sz="1400" b="0">
+                          <a:solidFill>
+                            <a:srgbClr val="20283F"/>
+                          </a:solidFill>
+                          <a:latin typeface="PingFang TC"/>
+                        </a:defRPr>
+                      </a:pPr>
+                      <a:r>
+                        <a:t>Male</a:t>
+                      </a:r>
+                    </a:p>
+                  </a:txBody>
+                  <a:tcPr marL="64008" marR="64008" marT="45720" marB="45720">
+                    <a:solidFill>
+                      <a:srgbClr val="FFFFFF"/>
+                    </a:solidFill>
+                  </a:tcPr>
+                </a:tc>
+                <a:tc>
+                  <a:txBody>
+                    <a:bodyPr/>
+                    <a:lstStyle/>
+                    <a:p>
+                      <a:pPr>
+                        <a:defRPr sz="1400" b="0">
+                          <a:solidFill>
+                            <a:srgbClr val="20283F"/>
+                          </a:solidFill>
+                          <a:latin typeface="PingFang TC"/>
+                        </a:defRPr>
+                      </a:pPr>
+                      <a:r>
+                        <a:t>19</a:t>
+                      </a:r>
+                    </a:p>
+                  </a:txBody>
+                  <a:tcPr marL="64008" marR="64008" marT="45720" marB="45720">
+                    <a:solidFill>
+                      <a:srgbClr val="FFFFFF"/>
+                    </a:solidFill>
+                  </a:tcPr>
+                </a:tc>
+                <a:tc>
+                  <a:txBody>
+                    <a:bodyPr/>
+                    <a:lstStyle/>
+                    <a:p>
+                      <a:pPr>
+                        <a:defRPr sz="1400" b="0">
+                          <a:solidFill>
+                            <a:srgbClr val="20283F"/>
+                          </a:solidFill>
+                          <a:latin typeface="PingFang TC"/>
+                        </a:defRPr>
+                      </a:pPr>
+                      <a:r>
+                        <a:t>1</a:t>
+                      </a:r>
+                    </a:p>
+                  </a:txBody>
+                  <a:tcPr marL="64008" marR="64008" marT="45720" marB="45720">
+                    <a:solidFill>
+                      <a:srgbClr val="FFFFFF"/>
+                    </a:solidFill>
+                  </a:tcPr>
+                </a:tc>
+                <a:tc>
+                  <a:txBody>
+                    <a:bodyPr/>
+                    <a:lstStyle/>
+                    <a:p>
+                      <a:pPr>
+                        <a:defRPr sz="1400" b="0">
+                          <a:solidFill>
+                            <a:srgbClr val="20283F"/>
+                          </a:solidFill>
+                          <a:latin typeface="PingFang TC"/>
+                        </a:defRPr>
+                      </a:pPr>
+                      <a:r>
+                        <a:t>420</a:t>
+                      </a:r>
+                    </a:p>
+                  </a:txBody>
+                  <a:tcPr marL="64008" marR="64008" marT="45720" marB="45720">
+                    <a:solidFill>
+                      <a:srgbClr val="FFFFFF"/>
+                    </a:solidFill>
+                  </a:tcPr>
+                </a:tc>
+                <a:tc>
+                  <a:txBody>
+                    <a:bodyPr/>
+                    <a:lstStyle/>
+                    <a:p>
+                      <a:pPr>
+                        <a:defRPr sz="1400" b="0">
+                          <a:solidFill>
+                            <a:srgbClr val="20283F"/>
+                          </a:solidFill>
+                          <a:latin typeface="PingFang TC"/>
+                        </a:defRPr>
+                      </a:pPr>
+                      <a:r>
+                        <a:t>Don't know</a:t>
+                      </a:r>
+                    </a:p>
+                  </a:txBody>
+                  <a:tcPr marL="64008" marR="64008" marT="45720" marB="45720">
+                    <a:solidFill>
+                      <a:srgbClr val="FFFFFF"/>
+                    </a:solidFill>
+                  </a:tcPr>
+                </a:tc>
+              </a:tr>
+              <a:tr h="448056">
+                <a:tc>
+                  <a:txBody>
+                    <a:bodyPr/>
+                    <a:lstStyle/>
+                    <a:p>
+                      <a:pPr>
+                        <a:defRPr sz="1400" b="0">
+                          <a:solidFill>
+                            <a:srgbClr val="20283F"/>
+                          </a:solidFill>
+                          <a:latin typeface="PingFang TC"/>
+                        </a:defRPr>
+                      </a:pPr>
+                      <a:r>
+                        <a:t>110119</a:t>
+                      </a:r>
+                    </a:p>
+                  </a:txBody>
+                  <a:tcPr marL="64008" marR="64008" marT="45720" marB="45720">
+                    <a:solidFill>
+                      <a:srgbClr val="E9ECF7"/>
+                    </a:solidFill>
+                  </a:tcPr>
+                </a:tc>
+                <a:tc>
+                  <a:txBody>
+                    <a:bodyPr/>
+                    <a:lstStyle/>
+                    <a:p>
+                      <a:pPr>
+                        <a:defRPr sz="1400" b="0">
+                          <a:solidFill>
+                            <a:srgbClr val="20283F"/>
+                          </a:solidFill>
+                          <a:latin typeface="PingFang TC"/>
+                        </a:defRPr>
+                      </a:pPr>
+                      <a:r>
+                        <a:t>Male</a:t>
+                      </a:r>
+                    </a:p>
+                  </a:txBody>
+                  <a:tcPr marL="64008" marR="64008" marT="45720" marB="45720">
+                    <a:solidFill>
+                      <a:srgbClr val="E9ECF7"/>
+                    </a:solidFill>
+                  </a:tcPr>
+                </a:tc>
+                <a:tc>
+                  <a:txBody>
+                    <a:bodyPr/>
+                    <a:lstStyle/>
+                    <a:p>
+                      <a:pPr>
+                        <a:defRPr sz="1400" b="0">
+                          <a:solidFill>
+                            <a:srgbClr val="20283F"/>
+                          </a:solidFill>
+                          <a:latin typeface="PingFang TC"/>
+                        </a:defRPr>
+                      </a:pPr>
+                      <a:r>
+                        <a:t>24</a:t>
+                      </a:r>
+                    </a:p>
+                  </a:txBody>
+                  <a:tcPr marL="64008" marR="64008" marT="45720" marB="45720">
+                    <a:solidFill>
+                      <a:srgbClr val="E9ECF7"/>
+                    </a:solidFill>
+                  </a:tcPr>
+                </a:tc>
+                <a:tc>
+                  <a:txBody>
+                    <a:bodyPr/>
+                    <a:lstStyle/>
+                    <a:p>
+                      <a:pPr>
+                        <a:defRPr sz="1400" b="0">
+                          <a:solidFill>
+                            <a:srgbClr val="20283F"/>
+                          </a:solidFill>
+                          <a:latin typeface="PingFang TC"/>
+                        </a:defRPr>
+                      </a:pPr>
+                      <a:r>
+                        <a:t>1</a:t>
+                      </a:r>
+                    </a:p>
+                  </a:txBody>
+                  <a:tcPr marL="64008" marR="64008" marT="45720" marB="45720">
+                    <a:solidFill>
+                      <a:srgbClr val="E9ECF7"/>
+                    </a:solidFill>
+                  </a:tcPr>
+                </a:tc>
+                <a:tc>
+                  <a:txBody>
+                    <a:bodyPr/>
+                    <a:lstStyle/>
+                    <a:p>
+                      <a:pPr>
+                        <a:defRPr sz="1400" b="0">
+                          <a:solidFill>
+                            <a:srgbClr val="20283F"/>
+                          </a:solidFill>
+                          <a:latin typeface="PingFang TC"/>
+                        </a:defRPr>
+                      </a:pPr>
+                      <a:r>
+                        <a:t>240</a:t>
+                      </a:r>
+                    </a:p>
+                  </a:txBody>
+                  <a:tcPr marL="64008" marR="64008" marT="45720" marB="45720">
+                    <a:solidFill>
+                      <a:srgbClr val="E9ECF7"/>
+                    </a:solidFill>
+                  </a:tcPr>
+                </a:tc>
+                <a:tc>
+                  <a:txBody>
+                    <a:bodyPr/>
+                    <a:lstStyle/>
+                    <a:p>
+                      <a:pPr>
+                        <a:defRPr sz="1400" b="0">
+                          <a:solidFill>
+                            <a:srgbClr val="20283F"/>
+                          </a:solidFill>
+                          <a:latin typeface="PingFang TC"/>
+                        </a:defRPr>
+                      </a:pPr>
+                      <a:r>
+                        <a:t>NT$300,000 - NT$399,999</a:t>
+                      </a:r>
+                    </a:p>
+                  </a:txBody>
+                  <a:tcPr marL="64008" marR="64008" marT="45720" marB="45720">
+                    <a:solidFill>
+                      <a:srgbClr val="E9ECF7"/>
+                    </a:solidFill>
+                  </a:tcPr>
+                </a:tc>
+              </a:tr>
+              <a:tr h="448056">
+                <a:tc>
+                  <a:txBody>
+                    <a:bodyPr/>
+                    <a:lstStyle/>
+                    <a:p>
+                      <a:pPr>
+                        <a:defRPr sz="1400" b="0">
+                          <a:solidFill>
+                            <a:srgbClr val="20283F"/>
+                          </a:solidFill>
+                          <a:latin typeface="PingFang TC"/>
+                        </a:defRPr>
+                      </a:pPr>
+                      <a:r>
+                        <a:t>110219</a:t>
+                      </a:r>
+                    </a:p>
+                  </a:txBody>
+                  <a:tcPr marL="64008" marR="64008" marT="45720" marB="45720">
+                    <a:solidFill>
+                      <a:srgbClr val="FFFFFF"/>
+                    </a:solidFill>
+                  </a:tcPr>
+                </a:tc>
+                <a:tc>
+                  <a:txBody>
+                    <a:bodyPr/>
+                    <a:lstStyle/>
+                    <a:p>
+                      <a:pPr>
+                        <a:defRPr sz="1400" b="0">
+                          <a:solidFill>
+                            <a:srgbClr val="20283F"/>
+                          </a:solidFill>
+                          <a:latin typeface="PingFang TC"/>
+                        </a:defRPr>
+                      </a:pPr>
+                      <a:r>
+                        <a:t>Male</a:t>
+                      </a:r>
+                    </a:p>
+                  </a:txBody>
+                  <a:tcPr marL="64008" marR="64008" marT="45720" marB="45720">
+                    <a:solidFill>
+                      <a:srgbClr val="FFFFFF"/>
+                    </a:solidFill>
+                  </a:tcPr>
+                </a:tc>
+                <a:tc>
+                  <a:txBody>
+                    <a:bodyPr/>
+                    <a:lstStyle/>
+                    <a:p>
+                      <a:pPr>
+                        <a:defRPr sz="1400" b="0">
+                          <a:solidFill>
+                            <a:srgbClr val="20283F"/>
+                          </a:solidFill>
+                          <a:latin typeface="PingFang TC"/>
+                        </a:defRPr>
+                      </a:pPr>
+                      <a:r>
+                        <a:t>19</a:t>
+                      </a:r>
+                    </a:p>
+                  </a:txBody>
+                  <a:tcPr marL="64008" marR="64008" marT="45720" marB="45720">
+                    <a:solidFill>
+                      <a:srgbClr val="FFFFFF"/>
+                    </a:solidFill>
+                  </a:tcPr>
+                </a:tc>
+                <a:tc>
+                  <a:txBody>
+                    <a:bodyPr/>
+                    <a:lstStyle/>
+                    <a:p>
+                      <a:pPr>
+                        <a:defRPr sz="1400" b="0">
+                          <a:solidFill>
+                            <a:srgbClr val="20283F"/>
+                          </a:solidFill>
+                          <a:latin typeface="PingFang TC"/>
+                        </a:defRPr>
+                      </a:pPr>
+                      <a:r>
+                        <a:t>1</a:t>
+                      </a:r>
+                    </a:p>
+                  </a:txBody>
+                  <a:tcPr marL="64008" marR="64008" marT="45720" marB="45720">
+                    <a:solidFill>
+                      <a:srgbClr val="FFFFFF"/>
+                    </a:solidFill>
+                  </a:tcPr>
+                </a:tc>
+                <a:tc>
+                  <a:txBody>
+                    <a:bodyPr/>
+                    <a:lstStyle/>
+                    <a:p>
+                      <a:pPr>
+                        <a:defRPr sz="1400" b="0">
+                          <a:solidFill>
+                            <a:srgbClr val="20283F"/>
+                          </a:solidFill>
+                          <a:latin typeface="PingFang TC"/>
+                        </a:defRPr>
+                      </a:pPr>
+                      <a:r>
+                        <a:t>480</a:t>
+                      </a:r>
+                    </a:p>
+                  </a:txBody>
+                  <a:tcPr marL="64008" marR="64008" marT="45720" marB="45720">
+                    <a:solidFill>
+                      <a:srgbClr val="FFFFFF"/>
+                    </a:solidFill>
+                  </a:tcPr>
+                </a:tc>
+                <a:tc>
+                  <a:txBody>
+                    <a:bodyPr/>
+                    <a:lstStyle/>
+                    <a:p>
+                      <a:pPr>
+                        <a:defRPr sz="1400" b="0">
+                          <a:solidFill>
+                            <a:srgbClr val="20283F"/>
+                          </a:solidFill>
+                          <a:latin typeface="PingFang TC"/>
+                        </a:defRPr>
+                      </a:pPr>
+                      <a:r>
+                        <a:t>Don't know</a:t>
+                      </a:r>
+                    </a:p>
+                  </a:txBody>
+                  <a:tcPr marL="64008" marR="64008" marT="45720" marB="45720">
+                    <a:solidFill>
+                      <a:srgbClr val="FFFFFF"/>
+                    </a:solidFill>
+                  </a:tcPr>
+                </a:tc>
+              </a:tr>
+            </a:tbl>
+          </a:graphicData>
+        </a:graphic>
+      </p:graphicFrame>
+      <p:sp>
+        <p:nvSpPr>
+          <p:cNvPr id="8" name="TextBox 7"/>
+          <p:cNvSpPr txBox="1"/>
+          <p:nvPr/>
+        </p:nvSpPr>
+        <p:spPr>
+          <a:xfrm>
+            <a:off x="594360" y="5532120"/>
+            <a:ext cx="10972800" cy="384048"/>
+          </a:xfrm>
+          <a:prstGeom prst="rect">
+            <a:avLst/>
+          </a:prstGeom>
+          <a:noFill/>
+        </p:spPr>
+        <p:txBody>
+          <a:bodyPr wrap="square" lIns="0" rIns="0" tIns="0" bIns="0">
+            <a:spAutoFit/>
+          </a:bodyPr>
+          <a:lstStyle/>
+          <a:p>
+            <a:pPr>
+              <a:defRPr sz="1700" b="1">
+                <a:solidFill>
+                  <a:srgbClr val="3B4A8C"/>
+                </a:solidFill>
+                <a:latin typeface="PingFang TC"/>
+              </a:defRPr>
+            </a:pPr>
+            <a:r>
+              <a:t>一起找：哪欄是識別碼？「地區代碼」能算平均嗎？</a:t>
+            </a:r>
+          </a:p>
+        </p:txBody>
+      </p:sp>
+      <p:sp>
+        <p:nvSpPr>
+          <p:cNvPr id="9" name="TextBox 8">
+            <a:hlinkClick r:id="rId2"/>
+          </p:cNvPr>
+          <p:cNvSpPr txBox="1"/>
+          <p:nvPr/>
+        </p:nvSpPr>
+        <p:spPr>
+          <a:xfrm>
+            <a:off x="594360" y="6007608"/>
+            <a:ext cx="4572000" cy="292608"/>
+          </a:xfrm>
+          <a:prstGeom prst="rect">
+            <a:avLst/>
+          </a:prstGeom>
+          <a:noFill/>
+        </p:spPr>
+        <p:txBody>
+          <a:bodyPr wrap="square" lIns="0" rIns="0" tIns="0" bIns="0">
+            <a:spAutoFit/>
+          </a:bodyPr>
+          <a:lstStyle/>
+          <a:p>
+            <a:pPr>
+              <a:defRPr sz="1400" b="1">
+                <a:solidFill>
+                  <a:srgbClr val="3B4A8C"/>
+                </a:solidFill>
+                <a:latin typeface="PingFang TC"/>
+              </a:defRPr>
+            </a:pPr>
+            <a:r>
+              <a:t>開啟完整原始 CSV →</a:t>
+            </a:r>
+          </a:p>
+        </p:txBody>
+      </p:sp>
+      <p:sp>
+        <p:nvSpPr>
+          <p:cNvPr id="10" name="TextBox 9"/>
+          <p:cNvSpPr txBox="1"/>
+          <p:nvPr/>
+        </p:nvSpPr>
+        <p:spPr>
+          <a:xfrm>
+            <a:off x="548640" y="6428232"/>
+            <a:ext cx="9144000" cy="228600"/>
+          </a:xfrm>
+          <a:prstGeom prst="rect">
+            <a:avLst/>
+          </a:prstGeom>
+          <a:noFill/>
+        </p:spPr>
+        <p:txBody>
+          <a:bodyPr wrap="square" lIns="0" rIns="0" tIns="0" bIns="0">
+            <a:spAutoFit/>
+          </a:bodyPr>
+          <a:lstStyle/>
+          <a:p>
+            <a:pPr>
+              <a:defRPr sz="1100" b="0">
+                <a:solidFill>
+                  <a:srgbClr val="596078"/>
+                </a:solidFill>
+                <a:latin typeface="PingFang TC"/>
+              </a:defRPr>
+            </a:pPr>
+            <a:r>
+              <a:t>臺北市立大學 公共事務學系｜郭毓倫 · 資料探勘</a:t>
+            </a:r>
+          </a:p>
+        </p:txBody>
+      </p:sp>
+      <p:sp>
+        <p:nvSpPr>
+          <p:cNvPr id="11" name="TextBox 10"/>
+          <p:cNvSpPr txBox="1"/>
+          <p:nvPr/>
+        </p:nvSpPr>
+        <p:spPr>
+          <a:xfrm>
+            <a:off x="11064240" y="6400800"/>
+            <a:ext cx="594360" cy="274320"/>
+          </a:xfrm>
+          <a:prstGeom prst="rect">
+            <a:avLst/>
+          </a:prstGeom>
+          <a:noFill/>
+        </p:spPr>
+        <p:txBody>
+          <a:bodyPr wrap="square" lIns="0" rIns="0" tIns="0" bIns="0">
+            <a:spAutoFit/>
+          </a:bodyPr>
+          <a:lstStyle/>
+          <a:p>
+            <a:pPr>
+              <a:defRPr sz="1200" b="0">
+                <a:solidFill>
+                  <a:srgbClr val="596078"/>
+                </a:solidFill>
+                <a:latin typeface="PingFang TC"/>
+              </a:defRPr>
+            </a:pPr>
+            <a:r>
+              <a:t>06</a:t>
             </a:r>
           </a:p>
         </p:txBody>
@@ -12128,7 +14144,7 @@
               <a:rPr>
                 <a:ea typeface="PingFang TC"/>
               </a:rPr>
-              <a:t>06</a:t>
+              <a:t>07</a:t>
             </a:r>
           </a:p>
         </p:txBody>
@@ -13045,7 +15061,7 @@
               <a:rPr>
                 <a:ea typeface="PingFang TC"/>
               </a:rPr>
-              <a:t>07</a:t>
+              <a:t>08</a:t>
             </a:r>
           </a:p>
         </p:txBody>
@@ -13679,7 +15695,7 @@
               <a:rPr>
                 <a:ea typeface="PingFang TC"/>
               </a:rPr>
-              <a:t>08</a:t>
+              <a:t>09</a:t>
             </a:r>
           </a:p>
         </p:txBody>
@@ -14424,7 +16440,7 @@
               <a:rPr>
                 <a:ea typeface="PingFang TC"/>
               </a:rPr>
-              <a:t>09</a:t>
+              <a:t>10</a:t>
             </a:r>
           </a:p>
         </p:txBody>

</xml_diff>